<commit_message>
Refresh revise reading group pptx output
</commit_message>
<xml_diff>
--- a/presentations/revise_reading_group/output/revise_reading_group.pptx
+++ b/presentations/revise_reading_group/output/revise_reading_group.pptx
@@ -503,8 +503,7 @@
           <a:p>
             <a:r>
               <a:rPr lang="en-US" dirty="0"/>
-              <a:t>Open with the goals of the workspace.
-Mention that the first task is to establish a stable editing and rendering scaffold.Slide 1 generated from slide_data.js.</a:t>
+              <a:t/>
             </a:r>
             <a:endParaRPr lang="en-US" dirty="0"/>
           </a:p>
@@ -592,8 +591,7 @@
           <a:p>
             <a:r>
               <a:rPr lang="en-US" dirty="0"/>
-              <a:t>Use this slide to explain how the repository is organized.
-Emphasize that the generator is intentionally small so later tasks can extend it safely.Slide 2 generated from slide_data.js.</a:t>
+              <a:t/>
             </a:r>
             <a:endParaRPr lang="en-US" dirty="0"/>
           </a:p>
@@ -945,13 +943,6 @@
 <file path=ppt/slides/slide1.xml><?xml version="1.0" encoding="utf-8"?>
 <p:sld xmlns:a="http://schemas.openxmlformats.org/drawingml/2006/main" xmlns:r="http://schemas.openxmlformats.org/officeDocument/2006/relationships" xmlns:p="http://schemas.openxmlformats.org/presentationml/2006/main">
   <p:cSld name="Slide 1">
-    <p:bg>
-      <p:bgPr>
-        <a:solidFill>
-          <a:srgbClr val="F7F4ED"/>
-        </a:solidFill>
-      </p:bgPr>
-    </p:bg>
     <p:spTree>
       <p:nvGrpSpPr>
         <p:cNvPr id="1" name=""/>
@@ -974,8 +965,8 @@
         </p:nvSpPr>
         <p:spPr>
           <a:xfrm>
-            <a:off x="731520" y="1234440"/>
-            <a:ext cx="10607040" cy="457200"/>
+            <a:off x="731520" y="914400"/>
+            <a:ext cx="10058400" cy="457200"/>
           </a:xfrm>
           <a:prstGeom prst="rect">
             <a:avLst/>
@@ -984,168 +975,21 @@
           <a:ln/>
         </p:spPr>
         <p:txBody>
-          <a:bodyPr wrap="square" lIns="0" tIns="0" rIns="0" bIns="0" rtlCol="0" anchor="ctr"/>
+          <a:bodyPr wrap="square" rtlCol="0" anchor="ctr"/>
           <a:lstStyle/>
           <a:p>
             <a:pPr indent="0" marL="0">
               <a:buNone/>
             </a:pPr>
             <a:r>
-              <a:rPr lang="en-US" sz="2800" b="1" dirty="0">
+              <a:rPr lang="en-US" dirty="0">
                 <a:solidFill>
-                  <a:srgbClr val="1C1B1F"/>
+                  <a:srgbClr val="000000"/>
                 </a:solidFill>
-                <a:latin typeface="Aptos Display" pitchFamily="34" charset="0"/>
-                <a:ea typeface="Aptos Display" pitchFamily="34" charset="-122"/>
-                <a:cs typeface="Aptos Display" pitchFamily="34" charset="-120"/>
               </a:rPr>
               <a:t>REVISE Reading Group</a:t>
             </a:r>
-            <a:endParaRPr lang="en-US" sz="2800" dirty="0"/>
-          </a:p>
-        </p:txBody>
-      </p:sp>
-      <p:sp>
-        <p:nvSpPr>
-          <p:cNvPr id="3" name="Text 1"/>
-          <p:cNvSpPr/>
-          <p:nvPr/>
-        </p:nvSpPr>
-        <p:spPr>
-          <a:xfrm>
-            <a:off x="731520" y="1783080"/>
-            <a:ext cx="10058400" cy="320040"/>
-          </a:xfrm>
-          <a:prstGeom prst="rect">
-            <a:avLst/>
-          </a:prstGeom>
-          <a:noFill/>
-          <a:ln/>
-        </p:spPr>
-        <p:txBody>
-          <a:bodyPr wrap="square" lIns="0" tIns="0" rIns="0" bIns="0" rtlCol="0" anchor="ctr"/>
-          <a:lstStyle/>
-          <a:p>
-            <a:pPr indent="0" marL="0">
-              <a:buNone/>
-            </a:pPr>
-            <a:r>
-              <a:rPr lang="en-US" sz="1400" dirty="0">
-                <a:solidFill>
-                  <a:srgbClr val="6C6875"/>
-                </a:solidFill>
-                <a:latin typeface="Aptos" pitchFamily="34" charset="0"/>
-                <a:ea typeface="Aptos" pitchFamily="34" charset="-122"/>
-                <a:cs typeface="Aptos" pitchFamily="34" charset="-120"/>
-              </a:rPr>
-              <a:t>Editable PPTX scaffold for slides, notes, and citations</a:t>
-            </a:r>
-            <a:endParaRPr lang="en-US" sz="1400" dirty="0"/>
-          </a:p>
-        </p:txBody>
-      </p:sp>
-      <p:sp>
-        <p:nvSpPr>
-          <p:cNvPr id="4" name="Shape 2"/>
-          <p:cNvSpPr/>
-          <p:nvPr/>
-        </p:nvSpPr>
-        <p:spPr>
-          <a:xfrm>
-            <a:off x="731520" y="2377440"/>
-            <a:ext cx="3657600" cy="73152"/>
-          </a:xfrm>
-          <a:prstGeom prst="rect">
-            <a:avLst/>
-          </a:prstGeom>
-          <a:solidFill>
-            <a:srgbClr val="8A5CF6"/>
-          </a:solidFill>
-          <a:ln w="12700">
-            <a:solidFill>
-              <a:srgbClr val="8A5CF6">
-                <a:alpha val="0"/>
-              </a:srgbClr>
-            </a:solidFill>
-            <a:prstDash val="solid"/>
-          </a:ln>
-        </p:spPr>
-      </p:sp>
-      <p:sp>
-        <p:nvSpPr>
-          <p:cNvPr id="5" name="Text 3"/>
-          <p:cNvSpPr/>
-          <p:nvPr/>
-        </p:nvSpPr>
-        <p:spPr>
-          <a:xfrm>
-            <a:off x="731520" y="2743200"/>
-            <a:ext cx="5029200" cy="274320"/>
-          </a:xfrm>
-          <a:prstGeom prst="rect">
-            <a:avLst/>
-          </a:prstGeom>
-          <a:noFill/>
-          <a:ln/>
-        </p:spPr>
-        <p:txBody>
-          <a:bodyPr wrap="square" lIns="0" tIns="0" rIns="0" bIns="0" rtlCol="0" anchor="ctr"/>
-          <a:lstStyle/>
-          <a:p>
-            <a:pPr indent="0" marL="0">
-              <a:buNone/>
-            </a:pPr>
-            <a:r>
-              <a:rPr lang="en-US" sz="1200" dirty="0">
-                <a:solidFill>
-                  <a:srgbClr val="2D2B32"/>
-                </a:solidFill>
-                <a:latin typeface="Aptos" pitchFamily="34" charset="0"/>
-                <a:ea typeface="Aptos" pitchFamily="34" charset="-122"/>
-                <a:cs typeface="Aptos" pitchFamily="34" charset="-120"/>
-              </a:rPr>
-              <a:t>Presenter: TBD</a:t>
-            </a:r>
-            <a:endParaRPr lang="en-US" sz="1200" dirty="0"/>
-          </a:p>
-        </p:txBody>
-      </p:sp>
-      <p:sp>
-        <p:nvSpPr>
-          <p:cNvPr id="6" name="Text 4"/>
-          <p:cNvSpPr/>
-          <p:nvPr/>
-        </p:nvSpPr>
-        <p:spPr>
-          <a:xfrm>
-            <a:off x="731520" y="3035808"/>
-            <a:ext cx="4572000" cy="228600"/>
-          </a:xfrm>
-          <a:prstGeom prst="rect">
-            <a:avLst/>
-          </a:prstGeom>
-          <a:noFill/>
-          <a:ln/>
-        </p:spPr>
-        <p:txBody>
-          <a:bodyPr wrap="square" lIns="0" tIns="0" rIns="0" bIns="0" rtlCol="0" anchor="ctr"/>
-          <a:lstStyle/>
-          <a:p>
-            <a:pPr indent="0" marL="0">
-              <a:buNone/>
-            </a:pPr>
-            <a:r>
-              <a:rPr lang="en-US" sz="1200" dirty="0">
-                <a:solidFill>
-                  <a:srgbClr val="6C6875"/>
-                </a:solidFill>
-                <a:latin typeface="Aptos" pitchFamily="34" charset="0"/>
-                <a:ea typeface="Aptos" pitchFamily="34" charset="-122"/>
-                <a:cs typeface="Aptos" pitchFamily="34" charset="-120"/>
-              </a:rPr>
-              <a:t>2026-04-20</a:t>
-            </a:r>
-            <a:endParaRPr lang="en-US" sz="1200" dirty="0"/>
+            <a:endParaRPr lang="en-US" dirty="0"/>
           </a:p>
         </p:txBody>
       </p:sp>
@@ -1160,13 +1004,6 @@
 <file path=ppt/slides/slide2.xml><?xml version="1.0" encoding="utf-8"?>
 <p:sld xmlns:a="http://schemas.openxmlformats.org/drawingml/2006/main" xmlns:r="http://schemas.openxmlformats.org/officeDocument/2006/relationships" xmlns:p="http://schemas.openxmlformats.org/presentationml/2006/main">
   <p:cSld name="Slide 2">
-    <p:bg>
-      <p:bgPr>
-        <a:solidFill>
-          <a:srgbClr val="F7F4ED"/>
-        </a:solidFill>
-      </p:bgPr>
-    </p:bg>
     <p:spTree>
       <p:nvGrpSpPr>
         <p:cNvPr id="1" name=""/>
@@ -1189,8 +1026,8 @@
         </p:nvSpPr>
         <p:spPr>
           <a:xfrm>
-            <a:off x="731520" y="502920"/>
-            <a:ext cx="10607040" cy="320040"/>
+            <a:off x="731520" y="914400"/>
+            <a:ext cx="10058400" cy="457200"/>
           </a:xfrm>
           <a:prstGeom prst="rect">
             <a:avLst/>
@@ -1199,166 +1036,21 @@
           <a:ln/>
         </p:spPr>
         <p:txBody>
-          <a:bodyPr wrap="square" lIns="0" tIns="0" rIns="0" bIns="0" rtlCol="0" anchor="ctr"/>
+          <a:bodyPr wrap="square" rtlCol="0" anchor="ctr"/>
           <a:lstStyle/>
           <a:p>
             <a:pPr indent="0" marL="0">
               <a:buNone/>
             </a:pPr>
             <a:r>
-              <a:rPr lang="en-US" sz="2400" b="1" dirty="0">
+              <a:rPr lang="en-US" dirty="0">
                 <a:solidFill>
-                  <a:srgbClr val="1C1B1F"/>
+                  <a:srgbClr val="000000"/>
                 </a:solidFill>
-                <a:latin typeface="Aptos Display" pitchFamily="34" charset="0"/>
-                <a:ea typeface="Aptos Display" pitchFamily="34" charset="-122"/>
-                <a:cs typeface="Aptos Display" pitchFamily="34" charset="-120"/>
               </a:rPr>
               <a:t>Workspace scaffold</a:t>
             </a:r>
-            <a:endParaRPr lang="en-US" sz="2400" dirty="0"/>
-          </a:p>
-        </p:txBody>
-      </p:sp>
-      <p:sp>
-        <p:nvSpPr>
-          <p:cNvPr id="3" name="Shape 1"/>
-          <p:cNvSpPr/>
-          <p:nvPr/>
-        </p:nvSpPr>
-        <p:spPr>
-          <a:xfrm>
-            <a:off x="731520" y="1325880"/>
-            <a:ext cx="10058400" cy="4297680"/>
-          </a:xfrm>
-          <a:prstGeom prst="roundRect">
-            <a:avLst>
-              <a:gd name="adj" fmla="val 2553"/>
-            </a:avLst>
-          </a:prstGeom>
-          <a:solidFill>
-            <a:srgbClr val="FFFDF9"/>
-          </a:solidFill>
-          <a:ln w="12700">
-            <a:solidFill>
-              <a:srgbClr val="D8D2C7"/>
-            </a:solidFill>
-            <a:prstDash val="solid"/>
-          </a:ln>
-        </p:spPr>
-      </p:sp>
-      <p:sp>
-        <p:nvSpPr>
-          <p:cNvPr id="4" name="Text 2"/>
-          <p:cNvSpPr/>
-          <p:nvPr/>
-        </p:nvSpPr>
-        <p:spPr>
-          <a:xfrm>
-            <a:off x="731520" y="1463040"/>
-            <a:ext cx="10149840" cy="4114800"/>
-          </a:xfrm>
-          <a:prstGeom prst="rect">
-            <a:avLst/>
-          </a:prstGeom>
-          <a:noFill/>
-          <a:ln/>
-        </p:spPr>
-        <p:txBody>
-          <a:bodyPr wrap="square" lIns="0" tIns="0" rIns="0" bIns="0" rtlCol="0" anchor="t"/>
-          <a:lstStyle/>
-          <a:p>
-            <a:pPr marL="177800" indent="-177800">
-              <a:buSzPct val="100000"/>
-              <a:buChar char="•"/>
-            </a:pPr>
-            <a:r>
-              <a:rPr lang="en-US" sz="1400" dirty="0">
-                <a:solidFill>
-                  <a:srgbClr val="2D2B32"/>
-                </a:solidFill>
-                <a:latin typeface="Aptos" pitchFamily="34" charset="0"/>
-                <a:ea typeface="Aptos" pitchFamily="34" charset="-122"/>
-                <a:cs typeface="Aptos" pitchFamily="34" charset="-120"/>
-              </a:rPr>
-              <a:t>Slide content lives in slide_data.js.</a:t>
-            </a:r>
-            <a:endParaRPr lang="en-US" sz="1400" dirty="0"/>
-          </a:p>
-          <a:p>
-            <a:pPr marL="177800" indent="-177800">
-              <a:buSzPct val="100000"/>
-              <a:buChar char="•"/>
-            </a:pPr>
-            <a:r>
-              <a:rPr lang="en-US" sz="1400" dirty="0">
-                <a:solidFill>
-                  <a:srgbClr val="2D2B32"/>
-                </a:solidFill>
-                <a:latin typeface="Aptos" pitchFamily="34" charset="0"/>
-                <a:ea typeface="Aptos" pitchFamily="34" charset="-122"/>
-                <a:cs typeface="Aptos" pitchFamily="34" charset="-120"/>
-              </a:rPr>
-              <a:t>Presentation styling lives in theme.js.</a:t>
-            </a:r>
-            <a:endParaRPr lang="en-US" sz="1400" dirty="0"/>
-          </a:p>
-          <a:p>
-            <a:pPr marL="177800" indent="-177800">
-              <a:buSzPct val="100000"/>
-              <a:buChar char="•"/>
-            </a:pPr>
-            <a:r>
-              <a:rPr lang="en-US" sz="1400" dirty="0">
-                <a:solidFill>
-                  <a:srgbClr val="2D2B32"/>
-                </a:solidFill>
-                <a:latin typeface="Aptos" pitchFamily="34" charset="0"/>
-                <a:ea typeface="Aptos" pitchFamily="34" charset="-122"/>
-                <a:cs typeface="Aptos" pitchFamily="34" charset="-120"/>
-              </a:rPr>
-              <a:t>Slide tracking, notes, and citations are kept in separate markdown files.</a:t>
-            </a:r>
-            <a:endParaRPr lang="en-US" sz="1400" dirty="0"/>
-          </a:p>
-        </p:txBody>
-      </p:sp>
-      <p:sp>
-        <p:nvSpPr>
-          <p:cNvPr id="5" name="Text 3"/>
-          <p:cNvSpPr/>
-          <p:nvPr/>
-        </p:nvSpPr>
-        <p:spPr>
-          <a:xfrm>
-            <a:off x="731520" y="6355080"/>
-            <a:ext cx="10058400" cy="182880"/>
-          </a:xfrm>
-          <a:prstGeom prst="rect">
-            <a:avLst/>
-          </a:prstGeom>
-          <a:noFill/>
-          <a:ln/>
-        </p:spPr>
-        <p:txBody>
-          <a:bodyPr wrap="square" lIns="0" tIns="0" rIns="0" bIns="0" rtlCol="0" anchor="ctr"/>
-          <a:lstStyle/>
-          <a:p>
-            <a:pPr indent="0" marL="0">
-              <a:buNone/>
-            </a:pPr>
-            <a:r>
-              <a:rPr lang="en-US" sz="900" dirty="0">
-                <a:solidFill>
-                  <a:srgbClr val="6C6875"/>
-                </a:solidFill>
-                <a:latin typeface="Aptos" pitchFamily="34" charset="0"/>
-                <a:ea typeface="Aptos" pitchFamily="34" charset="-122"/>
-                <a:cs typeface="Aptos" pitchFamily="34" charset="-120"/>
-              </a:rPr>
-              <a:t>Workspace scaffold slide for future content expansion.</a:t>
-            </a:r>
-            <a:endParaRPr lang="en-US" sz="900" dirty="0"/>
+            <a:endParaRPr lang="en-US" dirty="0"/>
           </a:p>
         </p:txBody>
       </p:sp>

</xml_diff>

<commit_message>
Fix revise reading group slide scaffold
</commit_message>
<xml_diff>
--- a/presentations/revise_reading_group/output/revise_reading_group.pptx
+++ b/presentations/revise_reading_group/output/revise_reading_group.pptx
@@ -987,7 +987,7 @@
                   <a:srgbClr val="000000"/>
                 </a:solidFill>
               </a:rPr>
-              <a:t>REVISE Reading Group</a:t>
+              <a:t>REVISE: Reasoning with Video Sparsity</a:t>
             </a:r>
             <a:endParaRPr lang="en-US" dirty="0"/>
           </a:p>
@@ -1048,7 +1048,7 @@
                   <a:srgbClr val="000000"/>
                 </a:solidFill>
               </a:rPr>
-              <a:t>Workspace scaffold</a:t>
+              <a:t>Roadmap</a:t>
             </a:r>
             <a:endParaRPr lang="en-US" dirty="0"/>
           </a:p>

</xml_diff>

<commit_message>
fix: harden revise deck layout renderers
</commit_message>
<xml_diff>
--- a/presentations/revise_reading_group/output/revise_reading_group.pptx
+++ b/presentations/revise_reading_group/output/revise_reading_group.pptx
@@ -3853,7 +3853,7 @@
                 <a:ea typeface="Aptos" pitchFamily="34" charset="-122"/>
                 <a:cs typeface="Aptos" pitchFamily="34" charset="-120"/>
               </a:rPr>
-              <a:t>Decision axis</a:t>
+              <a:t>Aspect</a:t>
             </a:r>
             <a:endParaRPr lang="en-US" sz="1400" dirty="0"/>
           </a:p>
@@ -4052,7 +4052,7 @@
                 <a:ea typeface="Aptos" pitchFamily="34" charset="-122"/>
                 <a:cs typeface="Aptos" pitchFamily="34" charset="-120"/>
               </a:rPr>
-              <a:t>First side</a:t>
+              <a:t>Family A</a:t>
             </a:r>
             <a:endParaRPr lang="en-US" sz="1400" dirty="0"/>
           </a:p>
@@ -4251,7 +4251,7 @@
                 <a:ea typeface="Aptos" pitchFamily="34" charset="-122"/>
                 <a:cs typeface="Aptos" pitchFamily="34" charset="-120"/>
               </a:rPr>
-              <a:t>Second side</a:t>
+              <a:t>Family B</a:t>
             </a:r>
             <a:endParaRPr lang="en-US" sz="1400" dirty="0"/>
           </a:p>
@@ -6439,115 +6439,18 @@
       </p:sp>
       <p:sp>
         <p:nvSpPr>
-          <p:cNvPr id="8" name="Text 6"/>
-          <p:cNvSpPr/>
-          <p:nvPr/>
-        </p:nvSpPr>
-        <p:spPr>
-          <a:xfrm>
-            <a:off x="658368" y="1444752"/>
-            <a:ext cx="3657600" cy="292608"/>
-          </a:xfrm>
-          <a:prstGeom prst="rect">
-            <a:avLst/>
-          </a:prstGeom>
-          <a:noFill/>
-          <a:ln/>
-        </p:spPr>
-        <p:txBody>
-          <a:bodyPr wrap="square" lIns="0" tIns="0" rIns="0" bIns="0" rtlCol="0" anchor="ctr"/>
-          <a:lstStyle/>
-          <a:p>
-            <a:pPr indent="0" marL="0">
-              <a:buNone/>
-            </a:pPr>
-            <a:r>
-              <a:rPr lang="en-US" sz="1500" b="1" dirty="0">
-                <a:solidFill>
-                  <a:srgbClr val="21344D"/>
-                </a:solidFill>
-                <a:latin typeface="Trebuchet MS" pitchFamily="34" charset="0"/>
-                <a:ea typeface="Trebuchet MS" pitchFamily="34" charset="-122"/>
-                <a:cs typeface="Trebuchet MS" pitchFamily="34" charset="-120"/>
-              </a:rPr>
-              <a:t>The framing for the talk</a:t>
-            </a:r>
-            <a:endParaRPr lang="en-US" sz="1500" dirty="0"/>
-          </a:p>
-        </p:txBody>
-      </p:sp>
-      <p:sp>
-        <p:nvSpPr>
-          <p:cNvPr id="9" name="Text 7"/>
-          <p:cNvSpPr/>
-          <p:nvPr/>
-        </p:nvSpPr>
-        <p:spPr>
-          <a:xfrm>
-            <a:off x="658368" y="1847088"/>
-            <a:ext cx="3474720" cy="1965960"/>
-          </a:xfrm>
-          <a:prstGeom prst="rect">
-            <a:avLst/>
-          </a:prstGeom>
-          <a:noFill/>
-          <a:ln/>
-        </p:spPr>
-        <p:txBody>
-          <a:bodyPr wrap="square" lIns="0" tIns="0" rIns="0" bIns="0" rtlCol="0" anchor="ctr">
-            <a:normAutofit/>
-          </a:bodyPr>
-          <a:lstStyle/>
-          <a:p>
-            <a:pPr indent="0" marL="0">
-              <a:buNone/>
-            </a:pPr>
-            <a:r>
-              <a:rPr lang="en-US" sz="1500" dirty="0">
-                <a:solidFill>
-                  <a:srgbClr val="303641"/>
-                </a:solidFill>
-                <a:latin typeface="Aptos" pitchFamily="34" charset="0"/>
-                <a:ea typeface="Aptos" pitchFamily="34" charset="-122"/>
-                <a:cs typeface="Aptos" pitchFamily="34" charset="-120"/>
-              </a:rPr>
-              <a:t>This opening slide should read like an editorial memo: concise thesis on the left, concrete takeaways on the right.</a:t>
-            </a:r>
-            <a:endParaRPr lang="en-US" sz="1500" dirty="0"/>
-          </a:p>
-          <a:p>
-            <a:pPr indent="0" marL="0">
-              <a:buNone/>
-            </a:pPr>
-            <a:r>
-              <a:rPr lang="en-US" sz="1500" dirty="0">
-                <a:solidFill>
-                  <a:srgbClr val="303641"/>
-                </a:solidFill>
-                <a:latin typeface="Aptos" pitchFamily="34" charset="0"/>
-                <a:ea typeface="Aptos" pitchFamily="34" charset="-122"/>
-                <a:cs typeface="Aptos" pitchFamily="34" charset="-120"/>
-              </a:rPr>
-              <a:t>The cards turn the preview bullets into distinct promises for the rest of the deck.</a:t>
-            </a:r>
-            <a:endParaRPr lang="en-US" sz="1500" dirty="0"/>
-          </a:p>
-        </p:txBody>
-      </p:sp>
-      <p:sp>
-        <p:nvSpPr>
-          <p:cNvPr id="10" name="Shape 8"/>
-          <p:cNvSpPr/>
-          <p:nvPr/>
-        </p:nvSpPr>
-        <p:spPr>
-          <a:xfrm>
-            <a:off x="4608576" y="1554480"/>
-            <a:ext cx="6924751" cy="1234440"/>
+          <p:cNvPr id="8" name="Shape 6"/>
+          <p:cNvSpPr/>
+          <p:nvPr/>
+        </p:nvSpPr>
+        <p:spPr>
+          <a:xfrm>
+            <a:off x="658368" y="1554480"/>
+            <a:ext cx="10874959" cy="1395984"/>
           </a:xfrm>
           <a:prstGeom prst="roundRect">
             <a:avLst>
-              <a:gd name="adj" fmla="val 5926"/>
+              <a:gd name="adj" fmla="val 5240"/>
             </a:avLst>
           </a:prstGeom>
           <a:solidFill>
@@ -6563,14 +6466,14 @@
       </p:sp>
       <p:sp>
         <p:nvSpPr>
-          <p:cNvPr id="11" name="Text 9"/>
-          <p:cNvSpPr/>
-          <p:nvPr/>
-        </p:nvSpPr>
-        <p:spPr>
-          <a:xfrm>
-            <a:off x="4791456" y="1691640"/>
-            <a:ext cx="6558991" cy="164592"/>
+          <p:cNvPr id="9" name="Text 7"/>
+          <p:cNvSpPr/>
+          <p:nvPr/>
+        </p:nvSpPr>
+        <p:spPr>
+          <a:xfrm>
+            <a:off x="841248" y="1691640"/>
+            <a:ext cx="10509199" cy="164592"/>
           </a:xfrm>
           <a:prstGeom prst="rect">
             <a:avLst/>
@@ -6602,14 +6505,14 @@
       </p:sp>
       <p:sp>
         <p:nvSpPr>
-          <p:cNvPr id="12" name="Text 10"/>
-          <p:cNvSpPr/>
-          <p:nvPr/>
-        </p:nvSpPr>
-        <p:spPr>
-          <a:xfrm>
-            <a:off x="4791456" y="1901952"/>
-            <a:ext cx="6558991" cy="310896"/>
+          <p:cNvPr id="10" name="Text 8"/>
+          <p:cNvSpPr/>
+          <p:nvPr/>
+        </p:nvSpPr>
+        <p:spPr>
+          <a:xfrm>
+            <a:off x="841248" y="1901952"/>
+            <a:ext cx="10509199" cy="310896"/>
           </a:xfrm>
           <a:prstGeom prst="rect">
             <a:avLst/>
@@ -6643,18 +6546,18 @@
       </p:sp>
       <p:sp>
         <p:nvSpPr>
-          <p:cNvPr id="13" name="Shape 11"/>
-          <p:cNvSpPr/>
-          <p:nvPr/>
-        </p:nvSpPr>
-        <p:spPr>
-          <a:xfrm>
-            <a:off x="4608576" y="2990088"/>
-            <a:ext cx="6924751" cy="1234440"/>
+          <p:cNvPr id="11" name="Shape 9"/>
+          <p:cNvSpPr/>
+          <p:nvPr/>
+        </p:nvSpPr>
+        <p:spPr>
+          <a:xfrm>
+            <a:off x="658368" y="3115056"/>
+            <a:ext cx="10874959" cy="1395984"/>
           </a:xfrm>
           <a:prstGeom prst="roundRect">
             <a:avLst>
-              <a:gd name="adj" fmla="val 5926"/>
+              <a:gd name="adj" fmla="val 5240"/>
             </a:avLst>
           </a:prstGeom>
           <a:solidFill>
@@ -6670,14 +6573,14 @@
       </p:sp>
       <p:sp>
         <p:nvSpPr>
-          <p:cNvPr id="14" name="Text 12"/>
-          <p:cNvSpPr/>
-          <p:nvPr/>
-        </p:nvSpPr>
-        <p:spPr>
-          <a:xfrm>
-            <a:off x="4791456" y="3127248"/>
-            <a:ext cx="6558991" cy="164592"/>
+          <p:cNvPr id="12" name="Text 10"/>
+          <p:cNvSpPr/>
+          <p:nvPr/>
+        </p:nvSpPr>
+        <p:spPr>
+          <a:xfrm>
+            <a:off x="841248" y="3252216"/>
+            <a:ext cx="10509199" cy="164592"/>
           </a:xfrm>
           <a:prstGeom prst="rect">
             <a:avLst/>
@@ -6709,14 +6612,14 @@
       </p:sp>
       <p:sp>
         <p:nvSpPr>
-          <p:cNvPr id="15" name="Text 13"/>
-          <p:cNvSpPr/>
-          <p:nvPr/>
-        </p:nvSpPr>
-        <p:spPr>
-          <a:xfrm>
-            <a:off x="4791456" y="3337560"/>
-            <a:ext cx="6558991" cy="310896"/>
+          <p:cNvPr id="13" name="Text 11"/>
+          <p:cNvSpPr/>
+          <p:nvPr/>
+        </p:nvSpPr>
+        <p:spPr>
+          <a:xfrm>
+            <a:off x="841248" y="3462528"/>
+            <a:ext cx="10509199" cy="310896"/>
           </a:xfrm>
           <a:prstGeom prst="rect">
             <a:avLst/>
@@ -6750,18 +6653,18 @@
       </p:sp>
       <p:sp>
         <p:nvSpPr>
-          <p:cNvPr id="16" name="Shape 14"/>
-          <p:cNvSpPr/>
-          <p:nvPr/>
-        </p:nvSpPr>
-        <p:spPr>
-          <a:xfrm>
-            <a:off x="4608576" y="4425696"/>
-            <a:ext cx="6924751" cy="1234440"/>
+          <p:cNvPr id="14" name="Shape 12"/>
+          <p:cNvSpPr/>
+          <p:nvPr/>
+        </p:nvSpPr>
+        <p:spPr>
+          <a:xfrm>
+            <a:off x="658368" y="4675632"/>
+            <a:ext cx="10874959" cy="1395984"/>
           </a:xfrm>
           <a:prstGeom prst="roundRect">
             <a:avLst>
-              <a:gd name="adj" fmla="val 5926"/>
+              <a:gd name="adj" fmla="val 5240"/>
             </a:avLst>
           </a:prstGeom>
           <a:solidFill>
@@ -6777,14 +6680,14 @@
       </p:sp>
       <p:sp>
         <p:nvSpPr>
-          <p:cNvPr id="17" name="Text 15"/>
-          <p:cNvSpPr/>
-          <p:nvPr/>
-        </p:nvSpPr>
-        <p:spPr>
-          <a:xfrm>
-            <a:off x="4791456" y="4562856"/>
-            <a:ext cx="6558991" cy="164592"/>
+          <p:cNvPr id="15" name="Text 13"/>
+          <p:cNvSpPr/>
+          <p:nvPr/>
+        </p:nvSpPr>
+        <p:spPr>
+          <a:xfrm>
+            <a:off x="841248" y="4812792"/>
+            <a:ext cx="10509199" cy="164592"/>
           </a:xfrm>
           <a:prstGeom prst="rect">
             <a:avLst/>
@@ -6816,14 +6719,14 @@
       </p:sp>
       <p:sp>
         <p:nvSpPr>
-          <p:cNvPr id="18" name="Text 16"/>
-          <p:cNvSpPr/>
-          <p:nvPr/>
-        </p:nvSpPr>
-        <p:spPr>
-          <a:xfrm>
-            <a:off x="4791456" y="4773168"/>
-            <a:ext cx="6558991" cy="310896"/>
+          <p:cNvPr id="16" name="Text 14"/>
+          <p:cNvSpPr/>
+          <p:nvPr/>
+        </p:nvSpPr>
+        <p:spPr>
+          <a:xfrm>
+            <a:off x="841248" y="5023104"/>
+            <a:ext cx="10509199" cy="310896"/>
           </a:xfrm>
           <a:prstGeom prst="rect">
             <a:avLst/>
@@ -6857,7 +6760,7 @@
       </p:sp>
       <p:sp>
         <p:nvSpPr>
-          <p:cNvPr id="19" name="Text 17"/>
+          <p:cNvPr id="17" name="Text 15"/>
           <p:cNvSpPr/>
           <p:nvPr/>
         </p:nvSpPr>

</xml_diff>